<commit_message>
Revert "Merge branch 'hyperspy/RELEASE_next_minor' into hyperspy/RELEASE_next_patch"
This reverts commit 7187f24035faf8bb935399b3579b57434c907184, reversing
changes made to 776cb0eb6eda5038f05cfa529359adc416ce9b83.
</commit_message>
<xml_diff>
--- a/doc/user_guide/images/HyperSpySignalOverview.pptx
+++ b/doc/user_guide/images/HyperSpySignalOverview.pptx
@@ -288,7 +288,7 @@
           <a:p>
             <a:fld id="{2E6F31E7-F7C9-4F09-AB17-051C3CE0F15A}" type="datetimeFigureOut">
               <a:rPr lang="en-GB" smtClean="0"/>
-              <a:t>14/07/16</a:t>
+              <a:t>08/07/2016</a:t>
             </a:fld>
             <a:endParaRPr lang="en-GB"/>
           </a:p>
@@ -330,7 +330,7 @@
           <a:p>
             <a:fld id="{EDB38D19-E595-49F3-A93E-1DDDDE122E43}" type="slidenum">
               <a:rPr lang="en-GB" smtClean="0"/>
-              <a:t>‹#›</a:t>
+              <a:t>‹Nr.›</a:t>
             </a:fld>
             <a:endParaRPr lang="en-GB"/>
           </a:p>
@@ -458,7 +458,7 @@
           <a:p>
             <a:fld id="{2E6F31E7-F7C9-4F09-AB17-051C3CE0F15A}" type="datetimeFigureOut">
               <a:rPr lang="en-GB" smtClean="0"/>
-              <a:t>14/07/16</a:t>
+              <a:t>08/07/2016</a:t>
             </a:fld>
             <a:endParaRPr lang="en-GB"/>
           </a:p>
@@ -500,7 +500,7 @@
           <a:p>
             <a:fld id="{EDB38D19-E595-49F3-A93E-1DDDDE122E43}" type="slidenum">
               <a:rPr lang="en-GB" smtClean="0"/>
-              <a:t>‹#›</a:t>
+              <a:t>‹Nr.›</a:t>
             </a:fld>
             <a:endParaRPr lang="en-GB"/>
           </a:p>
@@ -638,7 +638,7 @@
           <a:p>
             <a:fld id="{2E6F31E7-F7C9-4F09-AB17-051C3CE0F15A}" type="datetimeFigureOut">
               <a:rPr lang="en-GB" smtClean="0"/>
-              <a:t>14/07/16</a:t>
+              <a:t>08/07/2016</a:t>
             </a:fld>
             <a:endParaRPr lang="en-GB"/>
           </a:p>
@@ -680,7 +680,7 @@
           <a:p>
             <a:fld id="{EDB38D19-E595-49F3-A93E-1DDDDE122E43}" type="slidenum">
               <a:rPr lang="en-GB" smtClean="0"/>
-              <a:t>‹#›</a:t>
+              <a:t>‹Nr.›</a:t>
             </a:fld>
             <a:endParaRPr lang="en-GB"/>
           </a:p>
@@ -808,7 +808,7 @@
           <a:p>
             <a:fld id="{2E6F31E7-F7C9-4F09-AB17-051C3CE0F15A}" type="datetimeFigureOut">
               <a:rPr lang="en-GB" smtClean="0"/>
-              <a:t>14/07/16</a:t>
+              <a:t>08/07/2016</a:t>
             </a:fld>
             <a:endParaRPr lang="en-GB"/>
           </a:p>
@@ -850,7 +850,7 @@
           <a:p>
             <a:fld id="{EDB38D19-E595-49F3-A93E-1DDDDE122E43}" type="slidenum">
               <a:rPr lang="en-GB" smtClean="0"/>
-              <a:t>‹#›</a:t>
+              <a:t>‹Nr.›</a:t>
             </a:fld>
             <a:endParaRPr lang="en-GB"/>
           </a:p>
@@ -1054,7 +1054,7 @@
           <a:p>
             <a:fld id="{2E6F31E7-F7C9-4F09-AB17-051C3CE0F15A}" type="datetimeFigureOut">
               <a:rPr lang="en-GB" smtClean="0"/>
-              <a:t>14/07/16</a:t>
+              <a:t>08/07/2016</a:t>
             </a:fld>
             <a:endParaRPr lang="en-GB"/>
           </a:p>
@@ -1096,7 +1096,7 @@
           <a:p>
             <a:fld id="{EDB38D19-E595-49F3-A93E-1DDDDE122E43}" type="slidenum">
               <a:rPr lang="en-GB" smtClean="0"/>
-              <a:t>‹#›</a:t>
+              <a:t>‹Nr.›</a:t>
             </a:fld>
             <a:endParaRPr lang="en-GB"/>
           </a:p>
@@ -1342,7 +1342,7 @@
           <a:p>
             <a:fld id="{2E6F31E7-F7C9-4F09-AB17-051C3CE0F15A}" type="datetimeFigureOut">
               <a:rPr lang="en-GB" smtClean="0"/>
-              <a:t>14/07/16</a:t>
+              <a:t>08/07/2016</a:t>
             </a:fld>
             <a:endParaRPr lang="en-GB"/>
           </a:p>
@@ -1384,7 +1384,7 @@
           <a:p>
             <a:fld id="{EDB38D19-E595-49F3-A93E-1DDDDE122E43}" type="slidenum">
               <a:rPr lang="en-GB" smtClean="0"/>
-              <a:t>‹#›</a:t>
+              <a:t>‹Nr.›</a:t>
             </a:fld>
             <a:endParaRPr lang="en-GB"/>
           </a:p>
@@ -1764,7 +1764,7 @@
           <a:p>
             <a:fld id="{2E6F31E7-F7C9-4F09-AB17-051C3CE0F15A}" type="datetimeFigureOut">
               <a:rPr lang="en-GB" smtClean="0"/>
-              <a:t>14/07/16</a:t>
+              <a:t>08/07/2016</a:t>
             </a:fld>
             <a:endParaRPr lang="en-GB"/>
           </a:p>
@@ -1806,7 +1806,7 @@
           <a:p>
             <a:fld id="{EDB38D19-E595-49F3-A93E-1DDDDE122E43}" type="slidenum">
               <a:rPr lang="en-GB" smtClean="0"/>
-              <a:t>‹#›</a:t>
+              <a:t>‹Nr.›</a:t>
             </a:fld>
             <a:endParaRPr lang="en-GB"/>
           </a:p>
@@ -1882,7 +1882,7 @@
           <a:p>
             <a:fld id="{2E6F31E7-F7C9-4F09-AB17-051C3CE0F15A}" type="datetimeFigureOut">
               <a:rPr lang="en-GB" smtClean="0"/>
-              <a:t>14/07/16</a:t>
+              <a:t>08/07/2016</a:t>
             </a:fld>
             <a:endParaRPr lang="en-GB"/>
           </a:p>
@@ -1924,7 +1924,7 @@
           <a:p>
             <a:fld id="{EDB38D19-E595-49F3-A93E-1DDDDE122E43}" type="slidenum">
               <a:rPr lang="en-GB" smtClean="0"/>
-              <a:t>‹#›</a:t>
+              <a:t>‹Nr.›</a:t>
             </a:fld>
             <a:endParaRPr lang="en-GB"/>
           </a:p>
@@ -1977,7 +1977,7 @@
           <a:p>
             <a:fld id="{2E6F31E7-F7C9-4F09-AB17-051C3CE0F15A}" type="datetimeFigureOut">
               <a:rPr lang="en-GB" smtClean="0"/>
-              <a:t>14/07/16</a:t>
+              <a:t>08/07/2016</a:t>
             </a:fld>
             <a:endParaRPr lang="en-GB"/>
           </a:p>
@@ -2019,7 +2019,7 @@
           <a:p>
             <a:fld id="{EDB38D19-E595-49F3-A93E-1DDDDE122E43}" type="slidenum">
               <a:rPr lang="en-GB" smtClean="0"/>
-              <a:t>‹#›</a:t>
+              <a:t>‹Nr.›</a:t>
             </a:fld>
             <a:endParaRPr lang="en-GB"/>
           </a:p>
@@ -2254,7 +2254,7 @@
           <a:p>
             <a:fld id="{2E6F31E7-F7C9-4F09-AB17-051C3CE0F15A}" type="datetimeFigureOut">
               <a:rPr lang="en-GB" smtClean="0"/>
-              <a:t>14/07/16</a:t>
+              <a:t>08/07/2016</a:t>
             </a:fld>
             <a:endParaRPr lang="en-GB"/>
           </a:p>
@@ -2296,7 +2296,7 @@
           <a:p>
             <a:fld id="{EDB38D19-E595-49F3-A93E-1DDDDE122E43}" type="slidenum">
               <a:rPr lang="en-GB" smtClean="0"/>
-              <a:t>‹#›</a:t>
+              <a:t>‹Nr.›</a:t>
             </a:fld>
             <a:endParaRPr lang="en-GB"/>
           </a:p>
@@ -2507,7 +2507,7 @@
           <a:p>
             <a:fld id="{2E6F31E7-F7C9-4F09-AB17-051C3CE0F15A}" type="datetimeFigureOut">
               <a:rPr lang="en-GB" smtClean="0"/>
-              <a:t>14/07/16</a:t>
+              <a:t>08/07/2016</a:t>
             </a:fld>
             <a:endParaRPr lang="en-GB"/>
           </a:p>
@@ -2549,7 +2549,7 @@
           <a:p>
             <a:fld id="{EDB38D19-E595-49F3-A93E-1DDDDE122E43}" type="slidenum">
               <a:rPr lang="en-GB" smtClean="0"/>
-              <a:t>‹#›</a:t>
+              <a:t>‹Nr.›</a:t>
             </a:fld>
             <a:endParaRPr lang="en-GB"/>
           </a:p>
@@ -2720,7 +2720,7 @@
           <a:p>
             <a:fld id="{2E6F31E7-F7C9-4F09-AB17-051C3CE0F15A}" type="datetimeFigureOut">
               <a:rPr lang="en-GB" smtClean="0"/>
-              <a:t>14/07/16</a:t>
+              <a:t>08/07/2016</a:t>
             </a:fld>
             <a:endParaRPr lang="en-GB"/>
           </a:p>
@@ -2798,7 +2798,7 @@
           <a:p>
             <a:fld id="{EDB38D19-E595-49F3-A93E-1DDDDE122E43}" type="slidenum">
               <a:rPr lang="en-GB" smtClean="0"/>
-              <a:t>‹#›</a:t>
+              <a:t>‹Nr.›</a:t>
             </a:fld>
             <a:endParaRPr lang="en-GB"/>
           </a:p>
@@ -4716,7 +4716,17 @@
                   </a:schemeClr>
                 </a:solidFill>
               </a:rPr>
-              <a:t>Signal type: </a:t>
+              <a:t>Signal </a:t>
+            </a:r>
+            <a:r>
+              <a:rPr lang="de-DE" dirty="0" smtClean="0">
+                <a:solidFill>
+                  <a:schemeClr val="accent6">
+                    <a:lumMod val="75000"/>
+                  </a:schemeClr>
+                </a:solidFill>
+              </a:rPr>
+              <a:t>type: </a:t>
             </a:r>
             <a:r>
               <a:rPr lang="de-DE" i="1" dirty="0" err="1" smtClean="0">
@@ -4768,7 +4778,17 @@
                   </a:schemeClr>
                 </a:solidFill>
               </a:rPr>
-              <a:t>Signal type: </a:t>
+              <a:t>Signal </a:t>
+            </a:r>
+            <a:r>
+              <a:rPr lang="de-DE" dirty="0" smtClean="0">
+                <a:solidFill>
+                  <a:schemeClr val="accent6">
+                    <a:lumMod val="75000"/>
+                  </a:schemeClr>
+                </a:solidFill>
+              </a:rPr>
+              <a:t>type: </a:t>
             </a:r>
             <a:r>
               <a:rPr lang="de-DE" i="1" dirty="0" err="1" smtClean="0">
@@ -4921,6 +4941,13 @@
               </a:rPr>
               <a:t> Signal1D</a:t>
             </a:r>
+            <a:endParaRPr lang="de-DE" sz="1600" dirty="0" smtClean="0">
+              <a:solidFill>
+                <a:schemeClr val="accent2">
+                  <a:lumMod val="50000"/>
+                </a:schemeClr>
+              </a:solidFill>
+            </a:endParaRPr>
           </a:p>
         </p:txBody>
       </p:sp>
@@ -5026,134 +5053,6 @@
           <a:xfrm>
             <a:off x="3607450" y="3023914"/>
             <a:ext cx="1" cy="594962"/>
-          </a:xfrm>
-          <a:prstGeom prst="straightConnector1">
-            <a:avLst/>
-          </a:prstGeom>
-          <a:ln w="38100">
-            <a:solidFill>
-              <a:schemeClr val="accent2"/>
-            </a:solidFill>
-            <a:tailEnd type="arrow"/>
-          </a:ln>
-        </p:spPr>
-        <p:style>
-          <a:lnRef idx="1">
-            <a:schemeClr val="accent1"/>
-          </a:lnRef>
-          <a:fillRef idx="0">
-            <a:schemeClr val="accent1"/>
-          </a:fillRef>
-          <a:effectRef idx="0">
-            <a:schemeClr val="accent1"/>
-          </a:effectRef>
-          <a:fontRef idx="minor">
-            <a:schemeClr val="tx1"/>
-          </a:fontRef>
-        </p:style>
-      </p:cxnSp>
-      <p:sp>
-        <p:nvSpPr>
-          <p:cNvPr id="37" name="Abgerundetes Rechteck 5"/>
-          <p:cNvSpPr/>
-          <p:nvPr/>
-        </p:nvSpPr>
-        <p:spPr>
-          <a:xfrm>
-            <a:off x="6228184" y="4725144"/>
-            <a:ext cx="1224135" cy="559482"/>
-          </a:xfrm>
-          <a:prstGeom prst="roundRect">
-            <a:avLst/>
-          </a:prstGeom>
-          <a:solidFill>
-            <a:schemeClr val="accent2">
-              <a:lumMod val="60000"/>
-              <a:lumOff val="40000"/>
-            </a:schemeClr>
-          </a:solidFill>
-          <a:ln>
-            <a:solidFill>
-              <a:schemeClr val="accent2">
-                <a:lumMod val="75000"/>
-              </a:schemeClr>
-            </a:solidFill>
-          </a:ln>
-        </p:spPr>
-        <p:style>
-          <a:lnRef idx="2">
-            <a:schemeClr val="accent1">
-              <a:shade val="50000"/>
-            </a:schemeClr>
-          </a:lnRef>
-          <a:fillRef idx="1">
-            <a:schemeClr val="accent1"/>
-          </a:fillRef>
-          <a:effectRef idx="0">
-            <a:schemeClr val="accent1"/>
-          </a:effectRef>
-          <a:fontRef idx="minor">
-            <a:schemeClr val="lt1"/>
-          </a:fontRef>
-        </p:style>
-        <p:txBody>
-          <a:bodyPr rtlCol="0" anchor="ctr"/>
-          <a:lstStyle/>
-          <a:p>
-            <a:pPr algn="ctr"/>
-            <a:r>
-              <a:rPr lang="de-DE" sz="1600" dirty="0" err="1" smtClean="0">
-                <a:solidFill>
-                  <a:schemeClr val="accent2">
-                    <a:lumMod val="50000"/>
-                  </a:schemeClr>
-                </a:solidFill>
-              </a:rPr>
-              <a:t>Hologram</a:t>
-            </a:r>
-            <a:endParaRPr lang="de-DE" sz="1600" dirty="0" smtClean="0">
-              <a:solidFill>
-                <a:schemeClr val="accent2">
-                  <a:lumMod val="50000"/>
-                </a:schemeClr>
-              </a:solidFill>
-            </a:endParaRPr>
-          </a:p>
-          <a:p>
-            <a:pPr algn="ctr"/>
-            <a:r>
-              <a:rPr lang="de-DE" sz="1600" dirty="0" smtClean="0">
-                <a:solidFill>
-                  <a:schemeClr val="accent2">
-                    <a:lumMod val="50000"/>
-                  </a:schemeClr>
-                </a:solidFill>
-              </a:rPr>
-              <a:t>Image</a:t>
-            </a:r>
-            <a:endParaRPr lang="en-GB" sz="1600" dirty="0">
-              <a:solidFill>
-                <a:schemeClr val="accent2">
-                  <a:lumMod val="50000"/>
-                </a:schemeClr>
-              </a:solidFill>
-            </a:endParaRPr>
-          </a:p>
-        </p:txBody>
-      </p:sp>
-      <p:cxnSp>
-        <p:nvCxnSpPr>
-          <p:cNvPr id="13" name="Straight Arrow Connector 12"/>
-          <p:cNvCxnSpPr>
-            <a:stCxn id="6" idx="2"/>
-            <a:endCxn id="37" idx="0"/>
-          </p:cNvCxnSpPr>
-          <p:nvPr/>
-        </p:nvCxnSpPr>
-        <p:spPr>
-          <a:xfrm>
-            <a:off x="6840252" y="3023913"/>
-            <a:ext cx="0" cy="1701231"/>
           </a:xfrm>
           <a:prstGeom prst="straightConnector1">
             <a:avLst/>
@@ -5473,34 +5372,7 @@
       </a:bgFillStyleLst>
     </a:fmtScheme>
   </a:themeElements>
-  <a:objectDefaults>
-    <a:lnDef>
-      <a:spPr>
-        <a:ln w="38100">
-          <a:solidFill>
-            <a:schemeClr val="accent2"/>
-          </a:solidFill>
-          <a:tailEnd type="arrow"/>
-        </a:ln>
-      </a:spPr>
-      <a:bodyPr/>
-      <a:lstStyle/>
-      <a:style>
-        <a:lnRef idx="1">
-          <a:schemeClr val="accent1"/>
-        </a:lnRef>
-        <a:fillRef idx="0">
-          <a:schemeClr val="accent1"/>
-        </a:fillRef>
-        <a:effectRef idx="0">
-          <a:schemeClr val="accent1"/>
-        </a:effectRef>
-        <a:fontRef idx="minor">
-          <a:schemeClr val="tx1"/>
-        </a:fontRef>
-      </a:style>
-    </a:lnDef>
-  </a:objectDefaults>
+  <a:objectDefaults/>
   <a:extraClrSchemeLst/>
 </a:theme>
 </file>
</xml_diff>